<commit_message>
Updated plots 2 and 14
</commit_message>
<xml_diff>
--- a/paper-mstid-rt/pub_figures/TID.pptx
+++ b/paper-mstid-rt/pub_figures/TID.pptx
@@ -273,7 +273,7 @@
           <a:p>
             <a:fld id="{A9382490-085F-45B0-B756-BD60DC77582D}" type="datetimeFigureOut">
               <a:rPr lang="en-US" smtClean="0"/>
-              <a:t>5/3/2025</a:t>
+              <a:t>5/7/2025</a:t>
             </a:fld>
             <a:endParaRPr lang="en-US"/>
           </a:p>
@@ -471,7 +471,7 @@
           <a:p>
             <a:fld id="{A9382490-085F-45B0-B756-BD60DC77582D}" type="datetimeFigureOut">
               <a:rPr lang="en-US" smtClean="0"/>
-              <a:t>5/3/2025</a:t>
+              <a:t>5/7/2025</a:t>
             </a:fld>
             <a:endParaRPr lang="en-US"/>
           </a:p>
@@ -679,7 +679,7 @@
           <a:p>
             <a:fld id="{A9382490-085F-45B0-B756-BD60DC77582D}" type="datetimeFigureOut">
               <a:rPr lang="en-US" smtClean="0"/>
-              <a:t>5/3/2025</a:t>
+              <a:t>5/7/2025</a:t>
             </a:fld>
             <a:endParaRPr lang="en-US"/>
           </a:p>
@@ -877,7 +877,7 @@
           <a:p>
             <a:fld id="{A9382490-085F-45B0-B756-BD60DC77582D}" type="datetimeFigureOut">
               <a:rPr lang="en-US" smtClean="0"/>
-              <a:t>5/3/2025</a:t>
+              <a:t>5/7/2025</a:t>
             </a:fld>
             <a:endParaRPr lang="en-US"/>
           </a:p>
@@ -1152,7 +1152,7 @@
           <a:p>
             <a:fld id="{A9382490-085F-45B0-B756-BD60DC77582D}" type="datetimeFigureOut">
               <a:rPr lang="en-US" smtClean="0"/>
-              <a:t>5/3/2025</a:t>
+              <a:t>5/7/2025</a:t>
             </a:fld>
             <a:endParaRPr lang="en-US"/>
           </a:p>
@@ -1417,7 +1417,7 @@
           <a:p>
             <a:fld id="{A9382490-085F-45B0-B756-BD60DC77582D}" type="datetimeFigureOut">
               <a:rPr lang="en-US" smtClean="0"/>
-              <a:t>5/3/2025</a:t>
+              <a:t>5/7/2025</a:t>
             </a:fld>
             <a:endParaRPr lang="en-US"/>
           </a:p>
@@ -1829,7 +1829,7 @@
           <a:p>
             <a:fld id="{A9382490-085F-45B0-B756-BD60DC77582D}" type="datetimeFigureOut">
               <a:rPr lang="en-US" smtClean="0"/>
-              <a:t>5/3/2025</a:t>
+              <a:t>5/7/2025</a:t>
             </a:fld>
             <a:endParaRPr lang="en-US"/>
           </a:p>
@@ -1970,7 +1970,7 @@
           <a:p>
             <a:fld id="{A9382490-085F-45B0-B756-BD60DC77582D}" type="datetimeFigureOut">
               <a:rPr lang="en-US" smtClean="0"/>
-              <a:t>5/3/2025</a:t>
+              <a:t>5/7/2025</a:t>
             </a:fld>
             <a:endParaRPr lang="en-US"/>
           </a:p>
@@ -2083,7 +2083,7 @@
           <a:p>
             <a:fld id="{A9382490-085F-45B0-B756-BD60DC77582D}" type="datetimeFigureOut">
               <a:rPr lang="en-US" smtClean="0"/>
-              <a:t>5/3/2025</a:t>
+              <a:t>5/7/2025</a:t>
             </a:fld>
             <a:endParaRPr lang="en-US"/>
           </a:p>
@@ -2394,7 +2394,7 @@
           <a:p>
             <a:fld id="{A9382490-085F-45B0-B756-BD60DC77582D}" type="datetimeFigureOut">
               <a:rPr lang="en-US" smtClean="0"/>
-              <a:t>5/3/2025</a:t>
+              <a:t>5/7/2025</a:t>
             </a:fld>
             <a:endParaRPr lang="en-US"/>
           </a:p>
@@ -2682,7 +2682,7 @@
           <a:p>
             <a:fld id="{A9382490-085F-45B0-B756-BD60DC77582D}" type="datetimeFigureOut">
               <a:rPr lang="en-US" smtClean="0"/>
-              <a:t>5/3/2025</a:t>
+              <a:t>5/7/2025</a:t>
             </a:fld>
             <a:endParaRPr lang="en-US"/>
           </a:p>
@@ -2923,7 +2923,7 @@
           <a:p>
             <a:fld id="{A9382490-085F-45B0-B756-BD60DC77582D}" type="datetimeFigureOut">
               <a:rPr lang="en-US" smtClean="0"/>
-              <a:t>5/3/2025</a:t>
+              <a:t>5/7/2025</a:t>
             </a:fld>
             <a:endParaRPr lang="en-US"/>
           </a:p>
@@ -6152,10 +6152,10 @@
       </p:grpSpPr>
       <p:grpSp>
         <p:nvGrpSpPr>
-          <p:cNvPr id="134" name="Group 133">
+          <p:cNvPr id="7" name="Group 6">
             <a:extLst>
               <a:ext uri="{FF2B5EF4-FFF2-40B4-BE49-F238E27FC236}">
-                <a16:creationId xmlns:a16="http://schemas.microsoft.com/office/drawing/2014/main" id="{1B9C9ACA-0918-C82E-46FF-0C5402968028}"/>
+                <a16:creationId xmlns:a16="http://schemas.microsoft.com/office/drawing/2014/main" id="{4DA503A4-59E5-A27F-0B6B-1BF21A2F53FA}"/>
               </a:ext>
             </a:extLst>
           </p:cNvPr>
@@ -6164,12 +6164,48 @@
         </p:nvGrpSpPr>
         <p:grpSpPr>
           <a:xfrm>
-            <a:off x="756011" y="1576968"/>
-            <a:ext cx="10395640" cy="3536150"/>
-            <a:chOff x="756011" y="1576968"/>
-            <a:chExt cx="10395640" cy="3536150"/>
+            <a:off x="-38733" y="136908"/>
+            <a:ext cx="12269465" cy="5110271"/>
+            <a:chOff x="608335" y="1497358"/>
+            <a:chExt cx="10483175" cy="4209772"/>
           </a:xfrm>
         </p:grpSpPr>
+        <p:pic>
+          <p:nvPicPr>
+            <p:cNvPr id="3" name="Picture 2" descr="A map with a number of points&#10;&#10;AI-generated content may be incorrect.">
+              <a:extLst>
+                <a:ext uri="{FF2B5EF4-FFF2-40B4-BE49-F238E27FC236}">
+                  <a16:creationId xmlns:a16="http://schemas.microsoft.com/office/drawing/2014/main" id="{BDDDC78B-B828-1F54-6B50-23CF83FC18ED}"/>
+                </a:ext>
+              </a:extLst>
+            </p:cNvPr>
+            <p:cNvPicPr>
+              <a:picLocks noChangeAspect="1"/>
+            </p:cNvPicPr>
+            <p:nvPr/>
+          </p:nvPicPr>
+          <p:blipFill>
+            <a:blip r:embed="rId2">
+              <a:extLst>
+                <a:ext uri="{28A0092B-C50C-407E-A947-70E740481C1C}">
+                  <a14:useLocalDpi xmlns:a14="http://schemas.microsoft.com/office/drawing/2010/main" val="0"/>
+                </a:ext>
+              </a:extLst>
+            </a:blip>
+            <a:stretch>
+              <a:fillRect/>
+            </a:stretch>
+          </p:blipFill>
+          <p:spPr>
+            <a:xfrm>
+              <a:off x="7660869" y="1701208"/>
+              <a:ext cx="3329103" cy="4005922"/>
+            </a:xfrm>
+            <a:prstGeom prst="rect">
+              <a:avLst/>
+            </a:prstGeom>
+          </p:spPr>
+        </p:pic>
         <p:grpSp>
           <p:nvGrpSpPr>
             <p:cNvPr id="49" name="Group 48">
@@ -7104,8 +7140,8 @@
             </p:nvSpPr>
             <p:spPr>
               <a:xfrm rot="797264">
-                <a:off x="6691238" y="2604244"/>
-                <a:ext cx="779826" cy="276999"/>
+                <a:off x="6550639" y="2558078"/>
+                <a:ext cx="1061025" cy="369332"/>
               </a:xfrm>
               <a:prstGeom prst="rect">
                 <a:avLst/>
@@ -7119,7 +7155,7 @@
               <a:lstStyle/>
               <a:p>
                 <a:r>
-                  <a:rPr lang="en-US" sz="1200" dirty="0">
+                  <a:rPr lang="en-US" dirty="0">
                     <a:latin typeface="Calibri" panose="020F0502020204030204" pitchFamily="34" charset="0"/>
                     <a:ea typeface="Calibri" panose="020F0502020204030204" pitchFamily="34" charset="0"/>
                     <a:cs typeface="Calibri" panose="020F0502020204030204" pitchFamily="34" charset="0"/>
@@ -7143,8 +7179,8 @@
             </p:nvSpPr>
             <p:spPr>
               <a:xfrm rot="714879">
-                <a:off x="6598273" y="2867620"/>
-                <a:ext cx="785745" cy="276999"/>
+                <a:off x="6456688" y="2821454"/>
+                <a:ext cx="1068917" cy="369332"/>
               </a:xfrm>
               <a:prstGeom prst="rect">
                 <a:avLst/>
@@ -7158,7 +7194,7 @@
               <a:lstStyle/>
               <a:p>
                 <a:r>
-                  <a:rPr lang="en-US" sz="1200" dirty="0">
+                  <a:rPr lang="en-US" dirty="0">
                     <a:latin typeface="Calibri" panose="020F0502020204030204" pitchFamily="34" charset="0"/>
                     <a:ea typeface="Calibri" panose="020F0502020204030204" pitchFamily="34" charset="0"/>
                     <a:cs typeface="Calibri" panose="020F0502020204030204" pitchFamily="34" charset="0"/>
@@ -7182,8 +7218,8 @@
             </p:nvSpPr>
             <p:spPr>
               <a:xfrm rot="671485">
-                <a:off x="6542565" y="3080650"/>
-                <a:ext cx="809422" cy="276999"/>
+                <a:off x="6394074" y="3034484"/>
+                <a:ext cx="1106405" cy="369332"/>
               </a:xfrm>
               <a:prstGeom prst="rect">
                 <a:avLst/>
@@ -7197,7 +7233,7 @@
               <a:lstStyle/>
               <a:p>
                 <a:r>
-                  <a:rPr lang="en-US" sz="1200" dirty="0">
+                  <a:rPr lang="en-US" dirty="0">
                     <a:latin typeface="Calibri" panose="020F0502020204030204" pitchFamily="34" charset="0"/>
                     <a:ea typeface="Calibri" panose="020F0502020204030204" pitchFamily="34" charset="0"/>
                     <a:cs typeface="Calibri" panose="020F0502020204030204" pitchFamily="34" charset="0"/>
@@ -7450,7 +7486,7 @@
             <a:noFill/>
             <a:ln>
               <a:solidFill>
-                <a:srgbClr val="FFC000"/>
+                <a:srgbClr val="0070C0"/>
               </a:solidFill>
             </a:ln>
           </p:spPr>
@@ -7712,8 +7748,8 @@
           </p:nvSpPr>
           <p:spPr>
             <a:xfrm>
-              <a:off x="3572770" y="2239145"/>
-              <a:ext cx="2229649" cy="276999"/>
+              <a:off x="3572770" y="2195601"/>
+              <a:ext cx="2060179" cy="646331"/>
             </a:xfrm>
             <a:prstGeom prst="rect">
               <a:avLst/>
@@ -7721,18 +7757,28 @@
             <a:noFill/>
           </p:spPr>
           <p:txBody>
-            <a:bodyPr wrap="none" rtlCol="0">
+            <a:bodyPr wrap="square" rtlCol="0">
               <a:spAutoFit/>
             </a:bodyPr>
             <a:lstStyle/>
             <a:p>
               <a:r>
-                <a:rPr lang="en-US" sz="1200" dirty="0">
+                <a:rPr lang="en-US" dirty="0">
                   <a:latin typeface="Calibri" panose="020F0502020204030204" pitchFamily="34" charset="0"/>
                   <a:ea typeface="Calibri" panose="020F0502020204030204" pitchFamily="34" charset="0"/>
                   <a:cs typeface="Calibri" panose="020F0502020204030204" pitchFamily="34" charset="0"/>
                 </a:rPr>
-                <a:t>Ionospheric Plasma Irregularities</a:t>
+                <a:t>Ionospheric Plasma </a:t>
+              </a:r>
+            </a:p>
+            <a:p>
+              <a:r>
+                <a:rPr lang="en-US" dirty="0">
+                  <a:latin typeface="Calibri" panose="020F0502020204030204" pitchFamily="34" charset="0"/>
+                  <a:ea typeface="Calibri" panose="020F0502020204030204" pitchFamily="34" charset="0"/>
+                  <a:cs typeface="Calibri" panose="020F0502020204030204" pitchFamily="34" charset="0"/>
+                </a:rPr>
+                <a:t>Irregularities</a:t>
               </a:r>
             </a:p>
           </p:txBody>
@@ -7760,7 +7806,7 @@
             <a:noFill/>
           </p:spPr>
           <p:txBody>
-            <a:bodyPr wrap="none" rtlCol="0">
+            <a:bodyPr wrap="square" rtlCol="0">
               <a:spAutoFit/>
             </a:bodyPr>
             <a:lstStyle/>
@@ -7790,8 +7836,8 @@
           </p:nvSpPr>
           <p:spPr>
             <a:xfrm rot="1968219">
-              <a:off x="2387443" y="3458895"/>
-              <a:ext cx="2507866" cy="276999"/>
+              <a:off x="2509944" y="3393976"/>
+              <a:ext cx="2262864" cy="646331"/>
             </a:xfrm>
             <a:prstGeom prst="rect">
               <a:avLst/>
@@ -7799,13 +7845,13 @@
             <a:noFill/>
           </p:spPr>
           <p:txBody>
-            <a:bodyPr wrap="none" rtlCol="0">
+            <a:bodyPr wrap="square" rtlCol="0">
               <a:spAutoFit/>
             </a:bodyPr>
             <a:lstStyle/>
             <a:p>
               <a:r>
-                <a:rPr lang="en-US" sz="1200" dirty="0">
+                <a:rPr lang="en-US" dirty="0">
                   <a:solidFill>
                     <a:schemeClr val="accent5">
                       <a:lumMod val="50000"/>
@@ -7815,7 +7861,22 @@
                   <a:ea typeface="Calibri" panose="020F0502020204030204" pitchFamily="34" charset="0"/>
                   <a:cs typeface="Calibri" panose="020F0502020204030204" pitchFamily="34" charset="0"/>
                 </a:rPr>
-                <a:t>Ray-1: 1-hop E-region Ground Scatter</a:t>
+                <a:t>Ray-1: 1-hop E-region </a:t>
+              </a:r>
+            </a:p>
+            <a:p>
+              <a:r>
+                <a:rPr lang="en-US" dirty="0">
+                  <a:solidFill>
+                    <a:schemeClr val="accent5">
+                      <a:lumMod val="50000"/>
+                    </a:schemeClr>
+                  </a:solidFill>
+                  <a:latin typeface="Calibri" panose="020F0502020204030204" pitchFamily="34" charset="0"/>
+                  <a:ea typeface="Calibri" panose="020F0502020204030204" pitchFamily="34" charset="0"/>
+                  <a:cs typeface="Calibri" panose="020F0502020204030204" pitchFamily="34" charset="0"/>
+                </a:rPr>
+                <a:t>Ground Scatter</a:t>
               </a:r>
             </a:p>
           </p:txBody>
@@ -7834,8 +7895,8 @@
           </p:nvSpPr>
           <p:spPr>
             <a:xfrm rot="2638120">
-              <a:off x="4047652" y="3451756"/>
-              <a:ext cx="2503058" cy="276999"/>
+              <a:off x="4138297" y="3354179"/>
+              <a:ext cx="2256452" cy="646331"/>
             </a:xfrm>
             <a:prstGeom prst="rect">
               <a:avLst/>
@@ -7843,21 +7904,34 @@
             <a:noFill/>
           </p:spPr>
           <p:txBody>
-            <a:bodyPr wrap="none" rtlCol="0">
+            <a:bodyPr wrap="square" rtlCol="0">
               <a:spAutoFit/>
             </a:bodyPr>
             <a:lstStyle/>
             <a:p>
               <a:r>
-                <a:rPr lang="en-US" sz="1200" dirty="0">
+                <a:rPr lang="en-US" dirty="0">
                   <a:solidFill>
-                    <a:srgbClr val="FFC000"/>
+                    <a:srgbClr val="0070C0"/>
                   </a:solidFill>
                   <a:latin typeface="Calibri" panose="020F0502020204030204" pitchFamily="34" charset="0"/>
                   <a:ea typeface="Calibri" panose="020F0502020204030204" pitchFamily="34" charset="0"/>
                   <a:cs typeface="Calibri" panose="020F0502020204030204" pitchFamily="34" charset="0"/>
                 </a:rPr>
-                <a:t>Ray-2: 1-hop F-region Ground Scatter</a:t>
+                <a:t>Ray-2: 1-hop F-region </a:t>
+              </a:r>
+            </a:p>
+            <a:p>
+              <a:r>
+                <a:rPr lang="en-US" dirty="0">
+                  <a:solidFill>
+                    <a:srgbClr val="0070C0"/>
+                  </a:solidFill>
+                  <a:latin typeface="Calibri" panose="020F0502020204030204" pitchFamily="34" charset="0"/>
+                  <a:ea typeface="Calibri" panose="020F0502020204030204" pitchFamily="34" charset="0"/>
+                  <a:cs typeface="Calibri" panose="020F0502020204030204" pitchFamily="34" charset="0"/>
+                </a:rPr>
+                <a:t>Ground Scatter</a:t>
               </a:r>
             </a:p>
           </p:txBody>
@@ -7876,8 +7950,8 @@
           </p:nvSpPr>
           <p:spPr>
             <a:xfrm rot="20529758">
-              <a:off x="756011" y="2521171"/>
-              <a:ext cx="2308517" cy="461665"/>
+              <a:off x="608335" y="2428838"/>
+              <a:ext cx="2277290" cy="646331"/>
             </a:xfrm>
             <a:prstGeom prst="rect">
               <a:avLst/>
@@ -7885,13 +7959,13 @@
             <a:noFill/>
           </p:spPr>
           <p:txBody>
-            <a:bodyPr wrap="none" rtlCol="0">
+            <a:bodyPr wrap="square" rtlCol="0">
               <a:spAutoFit/>
             </a:bodyPr>
             <a:lstStyle/>
             <a:p>
               <a:r>
-                <a:rPr lang="en-US" sz="1200" dirty="0">
+                <a:rPr lang="en-US" dirty="0">
                   <a:solidFill>
                     <a:srgbClr val="00B050"/>
                   </a:solidFill>
@@ -7899,12 +7973,12 @@
                   <a:ea typeface="Calibri" panose="020F0502020204030204" pitchFamily="34" charset="0"/>
                   <a:cs typeface="Calibri" panose="020F0502020204030204" pitchFamily="34" charset="0"/>
                 </a:rPr>
-                <a:t>Ray-3: ½ hop F-region Ionospheric</a:t>
+                <a:t>Ray-3: ½ hop F-region </a:t>
               </a:r>
             </a:p>
             <a:p>
               <a:r>
-                <a:rPr lang="en-US" sz="1200" dirty="0">
+                <a:rPr lang="en-US" dirty="0">
                   <a:solidFill>
                     <a:srgbClr val="00B050"/>
                   </a:solidFill>
@@ -7912,7 +7986,7 @@
                   <a:ea typeface="Calibri" panose="020F0502020204030204" pitchFamily="34" charset="0"/>
                   <a:cs typeface="Calibri" panose="020F0502020204030204" pitchFamily="34" charset="0"/>
                 </a:rPr>
-                <a:t>Scatter</a:t>
+                <a:t>Ionospheric Scatter</a:t>
               </a:r>
             </a:p>
           </p:txBody>
@@ -7978,8 +8052,8 @@
           </p:nvSpPr>
           <p:spPr>
             <a:xfrm>
-              <a:off x="2783581" y="1834652"/>
-              <a:ext cx="880369" cy="276999"/>
+              <a:off x="2575367" y="1497358"/>
+              <a:ext cx="1234633" cy="369332"/>
             </a:xfrm>
             <a:prstGeom prst="rect">
               <a:avLst/>
@@ -7987,13 +8061,13 @@
             <a:noFill/>
           </p:spPr>
           <p:txBody>
-            <a:bodyPr wrap="none" rtlCol="0">
+            <a:bodyPr wrap="square" rtlCol="0">
               <a:spAutoFit/>
             </a:bodyPr>
             <a:lstStyle/>
             <a:p>
               <a:r>
-                <a:rPr lang="en-US" sz="1200" dirty="0">
+                <a:rPr lang="en-US" dirty="0">
                   <a:latin typeface="Calibri" panose="020F0502020204030204" pitchFamily="34" charset="0"/>
                   <a:ea typeface="Calibri" panose="020F0502020204030204" pitchFamily="34" charset="0"/>
                   <a:cs typeface="Calibri" panose="020F0502020204030204" pitchFamily="34" charset="0"/>
@@ -8005,10 +8079,10 @@
         </p:sp>
         <p:grpSp>
           <p:nvGrpSpPr>
-            <p:cNvPr id="131" name="Group 130">
+            <p:cNvPr id="117" name="Group 116">
               <a:extLst>
                 <a:ext uri="{FF2B5EF4-FFF2-40B4-BE49-F238E27FC236}">
-                  <a16:creationId xmlns:a16="http://schemas.microsoft.com/office/drawing/2014/main" id="{D87CB95B-6423-828B-6AAC-899679DA341D}"/>
+                  <a16:creationId xmlns:a16="http://schemas.microsoft.com/office/drawing/2014/main" id="{03B9EBB6-F8A0-85C8-1597-44C266CC3455}"/>
                 </a:ext>
               </a:extLst>
             </p:cNvPr>
@@ -8017,289 +8091,18 @@
           </p:nvGrpSpPr>
           <p:grpSpPr>
             <a:xfrm>
-              <a:off x="7693247" y="1576968"/>
-              <a:ext cx="3458404" cy="3536150"/>
-              <a:chOff x="7693247" y="1576968"/>
-              <a:chExt cx="3458404" cy="3536150"/>
+              <a:off x="7803048" y="3044668"/>
+              <a:ext cx="1848049" cy="2068450"/>
+              <a:chOff x="7803048" y="3044668"/>
+              <a:chExt cx="1848049" cy="2068450"/>
             </a:xfrm>
           </p:grpSpPr>
-          <p:pic>
-            <p:nvPicPr>
-              <p:cNvPr id="100" name="Picture 99">
+          <p:sp>
+            <p:nvSpPr>
+              <p:cNvPr id="102" name="Arc 101">
                 <a:extLst>
                   <a:ext uri="{FF2B5EF4-FFF2-40B4-BE49-F238E27FC236}">
-                    <a16:creationId xmlns:a16="http://schemas.microsoft.com/office/drawing/2014/main" id="{CF104F01-0626-1DEB-FCEC-7FBBC5EEC2D7}"/>
-                  </a:ext>
-                </a:extLst>
-              </p:cNvPr>
-              <p:cNvPicPr>
-                <a:picLocks noChangeAspect="1"/>
-              </p:cNvPicPr>
-              <p:nvPr/>
-            </p:nvPicPr>
-            <p:blipFill>
-              <a:blip r:embed="rId2"/>
-              <a:stretch>
-                <a:fillRect/>
-              </a:stretch>
-            </p:blipFill>
-            <p:spPr>
-              <a:xfrm>
-                <a:off x="7693247" y="1576968"/>
-                <a:ext cx="3458404" cy="3301617"/>
-              </a:xfrm>
-              <a:prstGeom prst="rect">
-                <a:avLst/>
-              </a:prstGeom>
-              <a:ln>
-                <a:solidFill>
-                  <a:schemeClr val="dk1"/>
-                </a:solidFill>
-              </a:ln>
-            </p:spPr>
-          </p:pic>
-          <p:grpSp>
-            <p:nvGrpSpPr>
-              <p:cNvPr id="117" name="Group 116">
-                <a:extLst>
-                  <a:ext uri="{FF2B5EF4-FFF2-40B4-BE49-F238E27FC236}">
-                    <a16:creationId xmlns:a16="http://schemas.microsoft.com/office/drawing/2014/main" id="{03B9EBB6-F8A0-85C8-1597-44C266CC3455}"/>
-                  </a:ext>
-                </a:extLst>
-              </p:cNvPr>
-              <p:cNvGrpSpPr/>
-              <p:nvPr/>
-            </p:nvGrpSpPr>
-            <p:grpSpPr>
-              <a:xfrm>
-                <a:off x="7803048" y="3044668"/>
-                <a:ext cx="1848049" cy="2068450"/>
-                <a:chOff x="7803048" y="3044668"/>
-                <a:chExt cx="1848049" cy="2068450"/>
-              </a:xfrm>
-            </p:grpSpPr>
-            <p:sp>
-              <p:nvSpPr>
-                <p:cNvPr id="102" name="Arc 101">
-                  <a:extLst>
-                    <a:ext uri="{FF2B5EF4-FFF2-40B4-BE49-F238E27FC236}">
-                      <a16:creationId xmlns:a16="http://schemas.microsoft.com/office/drawing/2014/main" id="{E214FC43-0455-DB1C-F307-DD031146F925}"/>
-                    </a:ext>
-                  </a:extLst>
-                </p:cNvPr>
-                <p:cNvSpPr/>
-                <p:nvPr/>
-              </p:nvSpPr>
-              <p:spPr>
-                <a:xfrm>
-                  <a:off x="7996816" y="3704169"/>
-                  <a:ext cx="877594" cy="1174024"/>
-                </a:xfrm>
-                <a:prstGeom prst="arc">
-                  <a:avLst>
-                    <a:gd name="adj1" fmla="val 16200000"/>
-                    <a:gd name="adj2" fmla="val 563031"/>
-                  </a:avLst>
-                </a:prstGeom>
-                <a:ln w="28575">
-                  <a:solidFill>
-                    <a:srgbClr val="7030A0"/>
-                  </a:solidFill>
-                </a:ln>
-              </p:spPr>
-              <p:style>
-                <a:lnRef idx="2">
-                  <a:schemeClr val="accent1"/>
-                </a:lnRef>
-                <a:fillRef idx="0">
-                  <a:schemeClr val="accent1"/>
-                </a:fillRef>
-                <a:effectRef idx="1">
-                  <a:schemeClr val="accent1"/>
-                </a:effectRef>
-                <a:fontRef idx="minor">
-                  <a:schemeClr val="tx1"/>
-                </a:fontRef>
-              </p:style>
-              <p:txBody>
-                <a:bodyPr rtlCol="0" anchor="ctr"/>
-                <a:lstStyle/>
-                <a:p>
-                  <a:pPr algn="ctr"/>
-                  <a:endParaRPr lang="en-US"/>
-                </a:p>
-              </p:txBody>
-            </p:sp>
-            <p:sp>
-              <p:nvSpPr>
-                <p:cNvPr id="103" name="Arc 102">
-                  <a:extLst>
-                    <a:ext uri="{FF2B5EF4-FFF2-40B4-BE49-F238E27FC236}">
-                      <a16:creationId xmlns:a16="http://schemas.microsoft.com/office/drawing/2014/main" id="{61C44AAC-CADC-58E7-84A6-AE555CB16B04}"/>
-                    </a:ext>
-                  </a:extLst>
-                </p:cNvPr>
-                <p:cNvSpPr/>
-                <p:nvPr/>
-              </p:nvSpPr>
-              <p:spPr>
-                <a:xfrm>
-                  <a:off x="7803048" y="3044668"/>
-                  <a:ext cx="1848049" cy="2068450"/>
-                </a:xfrm>
-                <a:prstGeom prst="arc">
-                  <a:avLst>
-                    <a:gd name="adj1" fmla="val 16200000"/>
-                    <a:gd name="adj2" fmla="val 881412"/>
-                  </a:avLst>
-                </a:prstGeom>
-                <a:ln w="28575">
-                  <a:solidFill>
-                    <a:srgbClr val="7030A0"/>
-                  </a:solidFill>
-                </a:ln>
-              </p:spPr>
-              <p:style>
-                <a:lnRef idx="2">
-                  <a:schemeClr val="accent1"/>
-                </a:lnRef>
-                <a:fillRef idx="0">
-                  <a:schemeClr val="accent1"/>
-                </a:fillRef>
-                <a:effectRef idx="1">
-                  <a:schemeClr val="accent1"/>
-                </a:effectRef>
-                <a:fontRef idx="minor">
-                  <a:schemeClr val="tx1"/>
-                </a:fontRef>
-              </p:style>
-              <p:txBody>
-                <a:bodyPr rtlCol="0" anchor="ctr"/>
-                <a:lstStyle/>
-                <a:p>
-                  <a:pPr algn="ctr"/>
-                  <a:endParaRPr lang="en-US" dirty="0"/>
-                </a:p>
-              </p:txBody>
-            </p:sp>
-            <p:grpSp>
-              <p:nvGrpSpPr>
-                <p:cNvPr id="110" name="Group 109">
-                  <a:extLst>
-                    <a:ext uri="{FF2B5EF4-FFF2-40B4-BE49-F238E27FC236}">
-                      <a16:creationId xmlns:a16="http://schemas.microsoft.com/office/drawing/2014/main" id="{3E35576F-4724-7C3D-778C-92594AD732D5}"/>
-                    </a:ext>
-                  </a:extLst>
-                </p:cNvPr>
-                <p:cNvGrpSpPr/>
-                <p:nvPr/>
-              </p:nvGrpSpPr>
-              <p:grpSpPr>
-                <a:xfrm>
-                  <a:off x="8435613" y="3044668"/>
-                  <a:ext cx="1191134" cy="1318481"/>
-                  <a:chOff x="8435613" y="3044668"/>
-                  <a:chExt cx="1191134" cy="1318481"/>
-                </a:xfrm>
-              </p:grpSpPr>
-              <p:cxnSp>
-                <p:nvCxnSpPr>
-                  <p:cNvPr id="105" name="Straight Connector 104">
-                    <a:extLst>
-                      <a:ext uri="{FF2B5EF4-FFF2-40B4-BE49-F238E27FC236}">
-                        <a16:creationId xmlns:a16="http://schemas.microsoft.com/office/drawing/2014/main" id="{070AFEE0-B63C-406D-6965-4398B58CD1D6}"/>
-                      </a:ext>
-                    </a:extLst>
-                  </p:cNvPr>
-                  <p:cNvCxnSpPr>
-                    <a:cxnSpLocks/>
-                    <a:stCxn id="102" idx="0"/>
-                    <a:endCxn id="103" idx="0"/>
-                  </p:cNvCxnSpPr>
-                  <p:nvPr/>
-                </p:nvCxnSpPr>
-                <p:spPr>
-                  <a:xfrm flipV="1">
-                    <a:off x="8435613" y="3044668"/>
-                    <a:ext cx="291459" cy="659501"/>
-                  </a:xfrm>
-                  <a:prstGeom prst="line">
-                    <a:avLst/>
-                  </a:prstGeom>
-                  <a:ln w="28575">
-                    <a:solidFill>
-                      <a:srgbClr val="7030A0"/>
-                    </a:solidFill>
-                  </a:ln>
-                </p:spPr>
-                <p:style>
-                  <a:lnRef idx="2">
-                    <a:schemeClr val="accent1"/>
-                  </a:lnRef>
-                  <a:fillRef idx="0">
-                    <a:schemeClr val="accent1"/>
-                  </a:fillRef>
-                  <a:effectRef idx="1">
-                    <a:schemeClr val="accent1"/>
-                  </a:effectRef>
-                  <a:fontRef idx="minor">
-                    <a:schemeClr val="tx1"/>
-                  </a:fontRef>
-                </p:style>
-              </p:cxnSp>
-              <p:cxnSp>
-                <p:nvCxnSpPr>
-                  <p:cNvPr id="106" name="Straight Connector 105">
-                    <a:extLst>
-                      <a:ext uri="{FF2B5EF4-FFF2-40B4-BE49-F238E27FC236}">
-                        <a16:creationId xmlns:a16="http://schemas.microsoft.com/office/drawing/2014/main" id="{198A2B6C-C604-6761-4E75-5421F0603016}"/>
-                      </a:ext>
-                    </a:extLst>
-                  </p:cNvPr>
-                  <p:cNvCxnSpPr>
-                    <a:cxnSpLocks/>
-                    <a:stCxn id="102" idx="2"/>
-                    <a:endCxn id="103" idx="2"/>
-                  </p:cNvCxnSpPr>
-                  <p:nvPr/>
-                </p:nvCxnSpPr>
-                <p:spPr>
-                  <a:xfrm flipV="1">
-                    <a:off x="8871100" y="4314754"/>
-                    <a:ext cx="755647" cy="48395"/>
-                  </a:xfrm>
-                  <a:prstGeom prst="line">
-                    <a:avLst/>
-                  </a:prstGeom>
-                  <a:ln w="28575">
-                    <a:solidFill>
-                      <a:srgbClr val="7030A0"/>
-                    </a:solidFill>
-                  </a:ln>
-                </p:spPr>
-                <p:style>
-                  <a:lnRef idx="2">
-                    <a:schemeClr val="accent1"/>
-                  </a:lnRef>
-                  <a:fillRef idx="0">
-                    <a:schemeClr val="accent1"/>
-                  </a:fillRef>
-                  <a:effectRef idx="1">
-                    <a:schemeClr val="accent1"/>
-                  </a:effectRef>
-                  <a:fontRef idx="minor">
-                    <a:schemeClr val="tx1"/>
-                  </a:fontRef>
-                </p:style>
-              </p:cxnSp>
-            </p:grpSp>
-          </p:grpSp>
-          <p:sp>
-            <p:nvSpPr>
-              <p:cNvPr id="124" name="Arc 123">
-                <a:extLst>
-                  <a:ext uri="{FF2B5EF4-FFF2-40B4-BE49-F238E27FC236}">
-                    <a16:creationId xmlns:a16="http://schemas.microsoft.com/office/drawing/2014/main" id="{47F42DEB-0B75-82D6-B8E1-64B0507F614D}"/>
+                    <a16:creationId xmlns:a16="http://schemas.microsoft.com/office/drawing/2014/main" id="{E214FC43-0455-DB1C-F307-DD031146F925}"/>
                   </a:ext>
                 </a:extLst>
               </p:cNvPr>
@@ -8308,7 +8111,59 @@
             </p:nvSpPr>
             <p:spPr>
               <a:xfrm>
-                <a:off x="8520826" y="2838224"/>
+                <a:off x="7996816" y="3704169"/>
+                <a:ext cx="877594" cy="1174024"/>
+              </a:xfrm>
+              <a:prstGeom prst="arc">
+                <a:avLst>
+                  <a:gd name="adj1" fmla="val 16200000"/>
+                  <a:gd name="adj2" fmla="val 563031"/>
+                </a:avLst>
+              </a:prstGeom>
+              <a:ln w="28575">
+                <a:solidFill>
+                  <a:srgbClr val="7030A0"/>
+                </a:solidFill>
+              </a:ln>
+            </p:spPr>
+            <p:style>
+              <a:lnRef idx="2">
+                <a:schemeClr val="accent1"/>
+              </a:lnRef>
+              <a:fillRef idx="0">
+                <a:schemeClr val="accent1"/>
+              </a:fillRef>
+              <a:effectRef idx="1">
+                <a:schemeClr val="accent1"/>
+              </a:effectRef>
+              <a:fontRef idx="minor">
+                <a:schemeClr val="tx1"/>
+              </a:fontRef>
+            </p:style>
+            <p:txBody>
+              <a:bodyPr rtlCol="0" anchor="ctr"/>
+              <a:lstStyle/>
+              <a:p>
+                <a:pPr algn="ctr"/>
+                <a:endParaRPr lang="en-US"/>
+              </a:p>
+            </p:txBody>
+          </p:sp>
+          <p:sp>
+            <p:nvSpPr>
+              <p:cNvPr id="103" name="Arc 102">
+                <a:extLst>
+                  <a:ext uri="{FF2B5EF4-FFF2-40B4-BE49-F238E27FC236}">
+                    <a16:creationId xmlns:a16="http://schemas.microsoft.com/office/drawing/2014/main" id="{61C44AAC-CADC-58E7-84A6-AE555CB16B04}"/>
+                  </a:ext>
+                </a:extLst>
+              </p:cNvPr>
+              <p:cNvSpPr/>
+              <p:nvPr/>
+            </p:nvSpPr>
+            <p:spPr>
+              <a:xfrm>
+                <a:off x="7803048" y="3044668"/>
                 <a:ext cx="1848049" cy="2068450"/>
               </a:xfrm>
               <a:prstGeom prst="arc">
@@ -8319,7 +8174,7 @@
               </a:prstGeom>
               <a:ln w="28575">
                 <a:solidFill>
-                  <a:srgbClr val="FFC000"/>
+                  <a:srgbClr val="7030A0"/>
                 </a:solidFill>
               </a:ln>
             </p:spPr>
@@ -8346,148 +8201,311 @@
               </a:p>
             </p:txBody>
           </p:sp>
-          <p:sp>
-            <p:nvSpPr>
-              <p:cNvPr id="125" name="Arc 124">
+          <p:grpSp>
+            <p:nvGrpSpPr>
+              <p:cNvPr id="110" name="Group 109">
                 <a:extLst>
                   <a:ext uri="{FF2B5EF4-FFF2-40B4-BE49-F238E27FC236}">
-                    <a16:creationId xmlns:a16="http://schemas.microsoft.com/office/drawing/2014/main" id="{FBEDBCD3-5D61-E8B9-E1EA-15D58F1FC4C3}"/>
+                    <a16:creationId xmlns:a16="http://schemas.microsoft.com/office/drawing/2014/main" id="{3E35576F-4724-7C3D-778C-92594AD732D5}"/>
                   </a:ext>
                 </a:extLst>
               </p:cNvPr>
-              <p:cNvSpPr/>
+              <p:cNvGrpSpPr/>
               <p:nvPr/>
-            </p:nvSpPr>
-            <p:spPr>
+            </p:nvGrpSpPr>
+            <p:grpSpPr>
               <a:xfrm>
-                <a:off x="8032663" y="3021038"/>
-                <a:ext cx="1848049" cy="2068450"/>
+                <a:off x="8435613" y="3044668"/>
+                <a:ext cx="1191134" cy="1318481"/>
+                <a:chOff x="8435613" y="3044668"/>
+                <a:chExt cx="1191134" cy="1318481"/>
               </a:xfrm>
-              <a:prstGeom prst="arc">
-                <a:avLst>
-                  <a:gd name="adj1" fmla="val 17073580"/>
-                  <a:gd name="adj2" fmla="val 474089"/>
-                </a:avLst>
-              </a:prstGeom>
-              <a:ln w="28575">
-                <a:solidFill>
-                  <a:srgbClr val="FFC000"/>
-                </a:solidFill>
-              </a:ln>
-            </p:spPr>
-            <p:style>
-              <a:lnRef idx="2">
-                <a:schemeClr val="accent1"/>
-              </a:lnRef>
-              <a:fillRef idx="0">
-                <a:schemeClr val="accent1"/>
-              </a:fillRef>
-              <a:effectRef idx="1">
-                <a:schemeClr val="accent1"/>
-              </a:effectRef>
-              <a:fontRef idx="minor">
-                <a:schemeClr val="tx1"/>
-              </a:fontRef>
-            </p:style>
-            <p:txBody>
-              <a:bodyPr rtlCol="0" anchor="ctr"/>
-              <a:lstStyle/>
-              <a:p>
-                <a:pPr algn="ctr"/>
-                <a:endParaRPr lang="en-US" dirty="0"/>
-              </a:p>
-            </p:txBody>
-          </p:sp>
-          <p:cxnSp>
-            <p:nvCxnSpPr>
-              <p:cNvPr id="127" name="Straight Connector 126">
-                <a:extLst>
-                  <a:ext uri="{FF2B5EF4-FFF2-40B4-BE49-F238E27FC236}">
-                    <a16:creationId xmlns:a16="http://schemas.microsoft.com/office/drawing/2014/main" id="{A28ABE7B-4F67-9C3C-75D9-ADD85556D231}"/>
-                  </a:ext>
-                </a:extLst>
-              </p:cNvPr>
-              <p:cNvCxnSpPr>
-                <a:stCxn id="125" idx="0"/>
-                <a:endCxn id="124" idx="0"/>
-              </p:cNvCxnSpPr>
-              <p:nvPr/>
-            </p:nvCxnSpPr>
-            <p:spPr>
-              <a:xfrm flipV="1">
-                <a:off x="9214628" y="2838224"/>
-                <a:ext cx="230222" cy="223927"/>
-              </a:xfrm>
-              <a:prstGeom prst="line">
-                <a:avLst/>
-              </a:prstGeom>
-              <a:ln>
-                <a:solidFill>
-                  <a:srgbClr val="FFC000"/>
-                </a:solidFill>
-              </a:ln>
-            </p:spPr>
-            <p:style>
-              <a:lnRef idx="2">
-                <a:schemeClr val="accent1"/>
-              </a:lnRef>
-              <a:fillRef idx="0">
-                <a:schemeClr val="accent1"/>
-              </a:fillRef>
-              <a:effectRef idx="1">
-                <a:schemeClr val="accent1"/>
-              </a:effectRef>
-              <a:fontRef idx="minor">
-                <a:schemeClr val="tx1"/>
-              </a:fontRef>
-            </p:style>
-          </p:cxnSp>
-          <p:cxnSp>
-            <p:nvCxnSpPr>
-              <p:cNvPr id="128" name="Straight Connector 127">
-                <a:extLst>
-                  <a:ext uri="{FF2B5EF4-FFF2-40B4-BE49-F238E27FC236}">
-                    <a16:creationId xmlns:a16="http://schemas.microsoft.com/office/drawing/2014/main" id="{F71293CB-1E86-EB72-BCE5-6F660D00A867}"/>
-                  </a:ext>
-                </a:extLst>
-              </p:cNvPr>
-              <p:cNvCxnSpPr>
-                <a:cxnSpLocks/>
-                <a:stCxn id="125" idx="2"/>
-                <a:endCxn id="124" idx="2"/>
-              </p:cNvCxnSpPr>
-              <p:nvPr/>
-            </p:nvCxnSpPr>
-            <p:spPr>
-              <a:xfrm flipV="1">
-                <a:off x="9873689" y="4108310"/>
-                <a:ext cx="470836" cy="74222"/>
-              </a:xfrm>
-              <a:prstGeom prst="line">
-                <a:avLst/>
-              </a:prstGeom>
-              <a:ln>
-                <a:solidFill>
-                  <a:srgbClr val="FFC000"/>
-                </a:solidFill>
-              </a:ln>
-            </p:spPr>
-            <p:style>
-              <a:lnRef idx="2">
-                <a:schemeClr val="accent1"/>
-              </a:lnRef>
-              <a:fillRef idx="0">
-                <a:schemeClr val="accent1"/>
-              </a:fillRef>
-              <a:effectRef idx="1">
-                <a:schemeClr val="accent1"/>
-              </a:effectRef>
-              <a:fontRef idx="minor">
-                <a:schemeClr val="tx1"/>
-              </a:fontRef>
-            </p:style>
-          </p:cxnSp>
+            </p:grpSpPr>
+            <p:cxnSp>
+              <p:nvCxnSpPr>
+                <p:cNvPr id="105" name="Straight Connector 104">
+                  <a:extLst>
+                    <a:ext uri="{FF2B5EF4-FFF2-40B4-BE49-F238E27FC236}">
+                      <a16:creationId xmlns:a16="http://schemas.microsoft.com/office/drawing/2014/main" id="{070AFEE0-B63C-406D-6965-4398B58CD1D6}"/>
+                    </a:ext>
+                  </a:extLst>
+                </p:cNvPr>
+                <p:cNvCxnSpPr>
+                  <a:cxnSpLocks/>
+                  <a:stCxn id="102" idx="0"/>
+                  <a:endCxn id="103" idx="0"/>
+                </p:cNvCxnSpPr>
+                <p:nvPr/>
+              </p:nvCxnSpPr>
+              <p:spPr>
+                <a:xfrm flipV="1">
+                  <a:off x="8435613" y="3044668"/>
+                  <a:ext cx="291459" cy="659501"/>
+                </a:xfrm>
+                <a:prstGeom prst="line">
+                  <a:avLst/>
+                </a:prstGeom>
+                <a:ln w="28575">
+                  <a:solidFill>
+                    <a:srgbClr val="7030A0"/>
+                  </a:solidFill>
+                </a:ln>
+              </p:spPr>
+              <p:style>
+                <a:lnRef idx="2">
+                  <a:schemeClr val="accent1"/>
+                </a:lnRef>
+                <a:fillRef idx="0">
+                  <a:schemeClr val="accent1"/>
+                </a:fillRef>
+                <a:effectRef idx="1">
+                  <a:schemeClr val="accent1"/>
+                </a:effectRef>
+                <a:fontRef idx="minor">
+                  <a:schemeClr val="tx1"/>
+                </a:fontRef>
+              </p:style>
+            </p:cxnSp>
+            <p:cxnSp>
+              <p:nvCxnSpPr>
+                <p:cNvPr id="106" name="Straight Connector 105">
+                  <a:extLst>
+                    <a:ext uri="{FF2B5EF4-FFF2-40B4-BE49-F238E27FC236}">
+                      <a16:creationId xmlns:a16="http://schemas.microsoft.com/office/drawing/2014/main" id="{198A2B6C-C604-6761-4E75-5421F0603016}"/>
+                    </a:ext>
+                  </a:extLst>
+                </p:cNvPr>
+                <p:cNvCxnSpPr>
+                  <a:cxnSpLocks/>
+                  <a:stCxn id="102" idx="2"/>
+                  <a:endCxn id="103" idx="2"/>
+                </p:cNvCxnSpPr>
+                <p:nvPr/>
+              </p:nvCxnSpPr>
+              <p:spPr>
+                <a:xfrm flipV="1">
+                  <a:off x="8871100" y="4314754"/>
+                  <a:ext cx="755647" cy="48395"/>
+                </a:xfrm>
+                <a:prstGeom prst="line">
+                  <a:avLst/>
+                </a:prstGeom>
+                <a:ln w="28575">
+                  <a:solidFill>
+                    <a:srgbClr val="7030A0"/>
+                  </a:solidFill>
+                </a:ln>
+              </p:spPr>
+              <p:style>
+                <a:lnRef idx="2">
+                  <a:schemeClr val="accent1"/>
+                </a:lnRef>
+                <a:fillRef idx="0">
+                  <a:schemeClr val="accent1"/>
+                </a:fillRef>
+                <a:effectRef idx="1">
+                  <a:schemeClr val="accent1"/>
+                </a:effectRef>
+                <a:fontRef idx="minor">
+                  <a:schemeClr val="tx1"/>
+                </a:fontRef>
+              </p:style>
+            </p:cxnSp>
+          </p:grpSp>
         </p:grpSp>
+        <p:sp>
+          <p:nvSpPr>
+            <p:cNvPr id="124" name="Arc 123">
+              <a:extLst>
+                <a:ext uri="{FF2B5EF4-FFF2-40B4-BE49-F238E27FC236}">
+                  <a16:creationId xmlns:a16="http://schemas.microsoft.com/office/drawing/2014/main" id="{47F42DEB-0B75-82D6-B8E1-64B0507F614D}"/>
+                </a:ext>
+              </a:extLst>
+            </p:cNvPr>
+            <p:cNvSpPr/>
+            <p:nvPr/>
+          </p:nvSpPr>
+          <p:spPr>
+            <a:xfrm>
+              <a:off x="8520826" y="2838224"/>
+              <a:ext cx="1848049" cy="2068450"/>
+            </a:xfrm>
+            <a:prstGeom prst="arc">
+              <a:avLst>
+                <a:gd name="adj1" fmla="val 16200000"/>
+                <a:gd name="adj2" fmla="val 881412"/>
+              </a:avLst>
+            </a:prstGeom>
+            <a:ln w="28575">
+              <a:solidFill>
+                <a:srgbClr val="0070C0"/>
+              </a:solidFill>
+            </a:ln>
+          </p:spPr>
+          <p:style>
+            <a:lnRef idx="2">
+              <a:schemeClr val="accent1"/>
+            </a:lnRef>
+            <a:fillRef idx="0">
+              <a:schemeClr val="accent1"/>
+            </a:fillRef>
+            <a:effectRef idx="1">
+              <a:schemeClr val="accent1"/>
+            </a:effectRef>
+            <a:fontRef idx="minor">
+              <a:schemeClr val="tx1"/>
+            </a:fontRef>
+          </p:style>
+          <p:txBody>
+            <a:bodyPr rtlCol="0" anchor="ctr"/>
+            <a:lstStyle/>
+            <a:p>
+              <a:pPr algn="ctr"/>
+              <a:endParaRPr lang="en-US" dirty="0"/>
+            </a:p>
+          </p:txBody>
+        </p:sp>
+        <p:sp>
+          <p:nvSpPr>
+            <p:cNvPr id="125" name="Arc 124">
+              <a:extLst>
+                <a:ext uri="{FF2B5EF4-FFF2-40B4-BE49-F238E27FC236}">
+                  <a16:creationId xmlns:a16="http://schemas.microsoft.com/office/drawing/2014/main" id="{FBEDBCD3-5D61-E8B9-E1EA-15D58F1FC4C3}"/>
+                </a:ext>
+              </a:extLst>
+            </p:cNvPr>
+            <p:cNvSpPr/>
+            <p:nvPr/>
+          </p:nvSpPr>
+          <p:spPr>
+            <a:xfrm>
+              <a:off x="8032663" y="3021038"/>
+              <a:ext cx="1848049" cy="2068450"/>
+            </a:xfrm>
+            <a:prstGeom prst="arc">
+              <a:avLst>
+                <a:gd name="adj1" fmla="val 17073580"/>
+                <a:gd name="adj2" fmla="val 474089"/>
+              </a:avLst>
+            </a:prstGeom>
+            <a:ln w="28575">
+              <a:solidFill>
+                <a:srgbClr val="0070C0"/>
+              </a:solidFill>
+            </a:ln>
+          </p:spPr>
+          <p:style>
+            <a:lnRef idx="2">
+              <a:schemeClr val="accent1"/>
+            </a:lnRef>
+            <a:fillRef idx="0">
+              <a:schemeClr val="accent1"/>
+            </a:fillRef>
+            <a:effectRef idx="1">
+              <a:schemeClr val="accent1"/>
+            </a:effectRef>
+            <a:fontRef idx="minor">
+              <a:schemeClr val="tx1"/>
+            </a:fontRef>
+          </p:style>
+          <p:txBody>
+            <a:bodyPr rtlCol="0" anchor="ctr"/>
+            <a:lstStyle/>
+            <a:p>
+              <a:pPr algn="ctr"/>
+              <a:endParaRPr lang="en-US" dirty="0"/>
+            </a:p>
+          </p:txBody>
+        </p:sp>
+        <p:cxnSp>
+          <p:nvCxnSpPr>
+            <p:cNvPr id="127" name="Straight Connector 126">
+              <a:extLst>
+                <a:ext uri="{FF2B5EF4-FFF2-40B4-BE49-F238E27FC236}">
+                  <a16:creationId xmlns:a16="http://schemas.microsoft.com/office/drawing/2014/main" id="{A28ABE7B-4F67-9C3C-75D9-ADD85556D231}"/>
+                </a:ext>
+              </a:extLst>
+            </p:cNvPr>
+            <p:cNvCxnSpPr>
+              <a:stCxn id="125" idx="0"/>
+              <a:endCxn id="124" idx="0"/>
+            </p:cNvCxnSpPr>
+            <p:nvPr/>
+          </p:nvCxnSpPr>
+          <p:spPr>
+            <a:xfrm flipV="1">
+              <a:off x="9214628" y="2838224"/>
+              <a:ext cx="230222" cy="223927"/>
+            </a:xfrm>
+            <a:prstGeom prst="line">
+              <a:avLst/>
+            </a:prstGeom>
+            <a:ln>
+              <a:solidFill>
+                <a:srgbClr val="0070C0"/>
+              </a:solidFill>
+            </a:ln>
+          </p:spPr>
+          <p:style>
+            <a:lnRef idx="2">
+              <a:schemeClr val="accent1"/>
+            </a:lnRef>
+            <a:fillRef idx="0">
+              <a:schemeClr val="accent1"/>
+            </a:fillRef>
+            <a:effectRef idx="1">
+              <a:schemeClr val="accent1"/>
+            </a:effectRef>
+            <a:fontRef idx="minor">
+              <a:schemeClr val="tx1"/>
+            </a:fontRef>
+          </p:style>
+        </p:cxnSp>
+        <p:cxnSp>
+          <p:nvCxnSpPr>
+            <p:cNvPr id="128" name="Straight Connector 127">
+              <a:extLst>
+                <a:ext uri="{FF2B5EF4-FFF2-40B4-BE49-F238E27FC236}">
+                  <a16:creationId xmlns:a16="http://schemas.microsoft.com/office/drawing/2014/main" id="{F71293CB-1E86-EB72-BCE5-6F660D00A867}"/>
+                </a:ext>
+              </a:extLst>
+            </p:cNvPr>
+            <p:cNvCxnSpPr>
+              <a:cxnSpLocks/>
+              <a:stCxn id="125" idx="2"/>
+              <a:endCxn id="124" idx="2"/>
+            </p:cNvCxnSpPr>
+            <p:nvPr/>
+          </p:nvCxnSpPr>
+          <p:spPr>
+            <a:xfrm flipV="1">
+              <a:off x="9873689" y="4108310"/>
+              <a:ext cx="470836" cy="74222"/>
+            </a:xfrm>
+            <a:prstGeom prst="line">
+              <a:avLst/>
+            </a:prstGeom>
+            <a:ln>
+              <a:solidFill>
+                <a:srgbClr val="0070C0"/>
+              </a:solidFill>
+            </a:ln>
+          </p:spPr>
+          <p:style>
+            <a:lnRef idx="2">
+              <a:schemeClr val="accent1"/>
+            </a:lnRef>
+            <a:fillRef idx="0">
+              <a:schemeClr val="accent1"/>
+            </a:fillRef>
+            <a:effectRef idx="1">
+              <a:schemeClr val="accent1"/>
+            </a:effectRef>
+            <a:fontRef idx="minor">
+              <a:schemeClr val="tx1"/>
+            </a:fontRef>
+          </p:style>
+        </p:cxnSp>
         <p:sp>
           <p:nvSpPr>
             <p:cNvPr id="132" name="TextBox 131">
@@ -8511,7 +8529,7 @@
             <a:noFill/>
           </p:spPr>
           <p:txBody>
-            <a:bodyPr wrap="none" rtlCol="0">
+            <a:bodyPr wrap="square" rtlCol="0">
               <a:spAutoFit/>
             </a:bodyPr>
             <a:lstStyle/>
@@ -8546,7 +8564,7 @@
             <a:noFill/>
           </p:spPr>
           <p:txBody>
-            <a:bodyPr wrap="none" rtlCol="0">
+            <a:bodyPr wrap="square" rtlCol="0">
               <a:spAutoFit/>
             </a:bodyPr>
             <a:lstStyle/>
@@ -8554,6 +8572,104 @@
               <a:r>
                 <a:rPr lang="en-US" dirty="0"/>
                 <a:t>(B)</a:t>
+              </a:r>
+            </a:p>
+          </p:txBody>
+        </p:sp>
+        <p:sp>
+          <p:nvSpPr>
+            <p:cNvPr id="4" name="TextBox 3">
+              <a:extLst>
+                <a:ext uri="{FF2B5EF4-FFF2-40B4-BE49-F238E27FC236}">
+                  <a16:creationId xmlns:a16="http://schemas.microsoft.com/office/drawing/2014/main" id="{E761CFD1-82CD-BC64-1AD6-117ADA0FA564}"/>
+                </a:ext>
+              </a:extLst>
+            </p:cNvPr>
+            <p:cNvSpPr txBox="1"/>
+            <p:nvPr/>
+          </p:nvSpPr>
+          <p:spPr>
+            <a:xfrm>
+              <a:off x="7720613" y="3668423"/>
+              <a:ext cx="1079398" cy="646331"/>
+            </a:xfrm>
+            <a:prstGeom prst="rect">
+              <a:avLst/>
+            </a:prstGeom>
+            <a:noFill/>
+          </p:spPr>
+          <p:txBody>
+            <a:bodyPr wrap="square" rtlCol="0">
+              <a:spAutoFit/>
+            </a:bodyPr>
+            <a:lstStyle/>
+            <a:p>
+              <a:r>
+                <a:rPr lang="en-US" dirty="0">
+                  <a:solidFill>
+                    <a:srgbClr val="FF0000"/>
+                  </a:solidFill>
+                </a:rPr>
+                <a:t>1-hop </a:t>
+              </a:r>
+            </a:p>
+            <a:p>
+              <a:r>
+                <a:rPr lang="en-US" dirty="0">
+                  <a:solidFill>
+                    <a:srgbClr val="FF0000"/>
+                  </a:solidFill>
+                </a:rPr>
+                <a:t>E Scatter</a:t>
+              </a:r>
+            </a:p>
+          </p:txBody>
+        </p:sp>
+        <p:sp>
+          <p:nvSpPr>
+            <p:cNvPr id="5" name="TextBox 4">
+              <a:extLst>
+                <a:ext uri="{FF2B5EF4-FFF2-40B4-BE49-F238E27FC236}">
+                  <a16:creationId xmlns:a16="http://schemas.microsoft.com/office/drawing/2014/main" id="{8CA39408-D38D-2F2B-2176-6D5D62F74FE7}"/>
+                </a:ext>
+              </a:extLst>
+            </p:cNvPr>
+            <p:cNvSpPr txBox="1"/>
+            <p:nvPr/>
+          </p:nvSpPr>
+          <p:spPr>
+            <a:xfrm>
+              <a:off x="10018524" y="2596447"/>
+              <a:ext cx="1072986" cy="646331"/>
+            </a:xfrm>
+            <a:prstGeom prst="rect">
+              <a:avLst/>
+            </a:prstGeom>
+            <a:noFill/>
+          </p:spPr>
+          <p:txBody>
+            <a:bodyPr wrap="square" rtlCol="0">
+              <a:spAutoFit/>
+            </a:bodyPr>
+            <a:lstStyle/>
+            <a:p>
+              <a:r>
+                <a:rPr lang="en-US" dirty="0">
+                  <a:solidFill>
+                    <a:srgbClr val="FF0000"/>
+                  </a:solidFill>
+                </a:rPr>
+                <a:t>1-hop </a:t>
+              </a:r>
+            </a:p>
+            <a:p>
+              <a:r>
+                <a:rPr lang="en-US" dirty="0">
+                  <a:solidFill>
+                    <a:srgbClr val="FF0000"/>
+                  </a:solidFill>
+                </a:rPr>
+                <a:t>F Scatter</a:t>
               </a:r>
             </a:p>
           </p:txBody>

</xml_diff>